<commit_message>
Corrige nome do grupo para F em todos os arquivos
Ajusta referencias de Grupo OF para Grupo F em README, roteiro, apresentacao (.md e .pptx) e cabecalho do main.py.

Co-Authored-By: Claude Opus 4.8 <noreply@anthropic.com>
</commit_message>
<xml_diff>
--- a/apresentacao/apresentacao.pptx
+++ b/apresentacao/apresentacao.pptx
@@ -2140,7 +2140,7 @@
                 <a:ea typeface="Calibri" pitchFamily="34" charset="-122"/>
                 <a:cs typeface="Calibri" pitchFamily="34" charset="-120"/>
               </a:rPr>
-              <a:t>Grupo OF</a:t>
+              <a:t>Grupo F</a:t>
             </a:r>
             <a:pPr indent="0" marL="0">
               <a:buNone/>
@@ -9651,7 +9651,7 @@
                 <a:ea typeface="Calibri" pitchFamily="34" charset="-122"/>
                 <a:cs typeface="Calibri" pitchFamily="34" charset="-120"/>
               </a:rPr>
-              <a:t>Grupo OF  ·  Obrigado!</a:t>
+              <a:t>Grupo F  ·  Obrigado!</a:t>
             </a:r>
             <a:endParaRPr lang="en-US" sz="1600" dirty="0"/>
           </a:p>

</xml_diff>